<commit_message>
Refine slide 3 typography probe
</commit_message>
<xml_diff>
--- a/tests/Lokad.OoxPdf.Tests/Cases/pptx-ladder-04-typography-slide3-narrow-cambria-probe.pptx
+++ b/tests/Lokad.OoxPdf.Tests/Cases/pptx-ladder-04-typography-slide3-narrow-cambria-probe.pptx
@@ -3348,10 +3348,19 @@
           </a:ln>
         </p:spPr>
         <p:txBody>
-          <a:bodyPr wrap="square"/>
-          <a:lstStyle/>
-          <a:p>
-            <a:pPr algn="l"/>
+          <a:bodyPr wrap="square">
+            <a:spAutoFit/>
+          </a:bodyPr>
+          <a:lstStyle/>
+          <a:p>
+            <a:pPr algn="l">
+              <a:spcBef>
+                <a:spcPct val="0"/>
+              </a:spcBef>
+              <a:spcAft>
+                <a:spcPts val="600"/>
+              </a:spcAft>
+            </a:pPr>
             <a:r>
               <a:rPr sz="1400" b="1" kern="1200">
                 <a:latin typeface="Cambria Math"/>
@@ -3360,31 +3369,45 @@
             </a:r>
           </a:p>
           <a:p>
-            <a:pPr algn="l"/>
-            <a:r>
-              <a:rPr sz="1200" b="1" kern="1200">
+            <a:pPr algn="l">
+              <a:spcBef>
+                <a:spcPct val="0"/>
+              </a:spcBef>
+              <a:spcAft>
+                <a:spcPts val="600"/>
+              </a:spcAft>
+            </a:pPr>
+            <a:r>
+              <a:rPr sz="1200" kern="1200">
                 <a:latin typeface="Cambria Math"/>
               </a:rPr>
               <a:t>Inventory Optimization and Planning depend on local decisions across locations. The </a:t>
             </a:r>
             <a:r>
-              <a:rPr sz="1200" b="1" kern="1200">
+              <a:rPr sz="1200" kern="1200">
+                <a:highlight>
+                  <a:srgbClr val="FFFF00"/>
+                </a:highlight>
                 <a:latin typeface="Cambria Math"/>
-                <a:highlight>
-                  <a:srgbClr val="FFF200"/>
-                </a:highlight>
               </a:rPr>
               <a:t>AI</a:t>
             </a:r>
             <a:r>
-              <a:rPr sz="1200" b="1" kern="1200">
+              <a:rPr sz="1200" kern="1200">
                 <a:latin typeface="Cambria Math"/>
               </a:rPr>
               <a:t> workflow must keep words readable without parasite letter spacing.</a:t>
             </a:r>
           </a:p>
           <a:p>
-            <a:pPr algn="l"/>
+            <a:pPr algn="l">
+              <a:spcBef>
+                <a:spcPct val="0"/>
+              </a:spcBef>
+              <a:spcAft>
+                <a:spcPts val="600"/>
+              </a:spcAft>
+            </a:pPr>
             <a:r>
               <a:rPr sz="1200" kern="1200">
                 <a:latin typeface="Cambria Math"/>

</xml_diff>